<commit_message>
feat: publish verified payout evidence and resume cold wallet sync
</commit_message>
<xml_diff>
--- a/docs/submission/NightSafe-Wave2-Pitch.pptx
+++ b/docs/submission/NightSafe-Wave2-Pitch.pptx
@@ -2,19 +2,19 @@
 <file path=ppt/presentation.xml><?xml version="1.0" encoding="utf-8"?>
 <p:presentation xmlns:p="http://schemas.openxmlformats.org/presentationml/2006/main">
   <p:sldMasterIdLst>
-    <p:sldMasterId xmlns:r="http://schemas.openxmlformats.org/officeDocument/2006/relationships" id="2147483648" r:id="Rdb73f006dfcf4196"/>
+    <p:sldMasterId xmlns:r="http://schemas.openxmlformats.org/officeDocument/2006/relationships" id="2147483648" r:id="R619d0eb8f38c4693"/>
   </p:sldMasterIdLst>
   <p:notesMasterIdLst>
-    <p:notesMasterId xmlns:r="http://schemas.openxmlformats.org/officeDocument/2006/relationships" r:id="R82eb7fd55b8145b6"/>
+    <p:notesMasterId xmlns:r="http://schemas.openxmlformats.org/officeDocument/2006/relationships" r:id="Rb963b99ac4e14d5d"/>
   </p:notesMasterIdLst>
   <p:sldIdLst>
-    <p:sldId xmlns:r="http://schemas.openxmlformats.org/officeDocument/2006/relationships" id="256" r:id="R23a3621e3ad04137"/>
-    <p:sldId xmlns:r="http://schemas.openxmlformats.org/officeDocument/2006/relationships" id="257" r:id="Reb3725cad5e44e73"/>
-    <p:sldId xmlns:r="http://schemas.openxmlformats.org/officeDocument/2006/relationships" id="258" r:id="Rbd8d6c6545d541a9"/>
-    <p:sldId xmlns:r="http://schemas.openxmlformats.org/officeDocument/2006/relationships" id="259" r:id="R7c81225252994d1f"/>
-    <p:sldId xmlns:r="http://schemas.openxmlformats.org/officeDocument/2006/relationships" id="260" r:id="R5f73ed43d4fd41fe"/>
-    <p:sldId xmlns:r="http://schemas.openxmlformats.org/officeDocument/2006/relationships" id="261" r:id="Rca2a8b99423e4c09"/>
-    <p:sldId xmlns:r="http://schemas.openxmlformats.org/officeDocument/2006/relationships" id="262" r:id="Rd12d07988d854125"/>
+    <p:sldId xmlns:r="http://schemas.openxmlformats.org/officeDocument/2006/relationships" id="256" r:id="Rf2e1578f2f59433a"/>
+    <p:sldId xmlns:r="http://schemas.openxmlformats.org/officeDocument/2006/relationships" id="257" r:id="R5b1bda5120a84b39"/>
+    <p:sldId xmlns:r="http://schemas.openxmlformats.org/officeDocument/2006/relationships" id="258" r:id="Ree3aff06e89840b1"/>
+    <p:sldId xmlns:r="http://schemas.openxmlformats.org/officeDocument/2006/relationships" id="259" r:id="R349ab743d0e045d9"/>
+    <p:sldId xmlns:r="http://schemas.openxmlformats.org/officeDocument/2006/relationships" id="260" r:id="R8ca380be730846e6"/>
+    <p:sldId xmlns:r="http://schemas.openxmlformats.org/officeDocument/2006/relationships" id="261" r:id="Rb09e69f5043648b6"/>
+    <p:sldId xmlns:r="http://schemas.openxmlformats.org/officeDocument/2006/relationships" id="262" r:id="R69d19c1d277f4213"/>
   </p:sldIdLst>
   <p:sldSz cx="12192000" cy="6858000"/>
   <p:notesSz cx="6858000" cy="9144000"/>
@@ -798,7 +798,7 @@
           <a:lstStyle xmlns:a="http://schemas.openxmlformats.org/drawingml/2006/main"/>
           <a:p xmlns:a="http://schemas.openxmlformats.org/drawingml/2006/main">
             <a:r>
-              <a:t>Sources: git baseline e232902; tests/nightsafe.test.ts and tests/treasury.test.ts; src/App.tsx. TypeScript check and build passed. No Wave 1 entry. AKINDO live page showed a deadline of October 19 16:00 and active Wave 2 countdown on October 19: https://app.akindo.io/wave-hacks/jaMZjqPOBsLXvjdG. The static schedule differs.</a:t>
+              <a:t>Sources: git baseline e232902; tests/nightsafe.test.ts and tests/treasury.test.ts; src/App.tsx. Source: docs/submission/LOCAL_NETWORK_EVIDENCE.json. Real proofs and five transactions confirmed on a local Docker network. Units are native test-token base units. One operator controlled both signer files. Maintenance authority permanently locked. Public Preprod verification pending. TypeScript check and build passed. No Wave 1 entry. AKINDO live page showed a deadline of October 19 16:00 and active Wave 2 countdown on October 19: https://app.akindo.io/wave-hacks/jaMZjqPOBsLXvjdG. The static schedule differs.</a:t>
             </a:r>
           </a:p>
         </p:txBody>
@@ -915,7 +915,7 @@
           <p:cNvPr id="3" name="Title">
             <a:extLst xmlns:a="http://schemas.openxmlformats.org/drawingml/2006/main">
               <a:ext uri="{FF2B5EF4-FFF2-40B4-BE49-F238E27FC236}">
-                <a16:creationId xmlns:a16="http://schemas.microsoft.com/office/drawing/2014/main" id="{03ABC846-B034-44F1-9B4C-3427CDB6E4FA}"/>
+                <a16:creationId xmlns:a16="http://schemas.microsoft.com/office/drawing/2014/main" id="{E6EE279E-6967-440D-9D2C-27BB617797AF}"/>
               </a:ext>
             </a:extLst>
           </p:cNvPr>
@@ -1144,7 +1144,7 @@
           <p:cNvPr id="2" name="Subtitle">
             <a:extLst xmlns:a="http://schemas.openxmlformats.org/drawingml/2006/main">
               <a:ext uri="{FF2B5EF4-FFF2-40B4-BE49-F238E27FC236}">
-                <a16:creationId xmlns:a16="http://schemas.microsoft.com/office/drawing/2014/main" id="{307A2679-CD13-4BDC-8BB8-07CFA81C09A3}"/>
+                <a16:creationId xmlns:a16="http://schemas.microsoft.com/office/drawing/2014/main" id="{71B427A4-B374-4D61-8EFF-3FE9227EEF10}"/>
               </a:ext>
             </a:extLst>
           </p:cNvPr>
@@ -1390,7 +1390,7 @@
           <p:cNvPr id="2" name="Section title">
             <a:extLst xmlns:a="http://schemas.openxmlformats.org/drawingml/2006/main">
               <a:ext uri="{FF2B5EF4-FFF2-40B4-BE49-F238E27FC236}">
-                <a16:creationId xmlns:a16="http://schemas.microsoft.com/office/drawing/2014/main" id="{DD20B9B6-8DB9-4E6C-A40A-7A916E48AC28}"/>
+                <a16:creationId xmlns:a16="http://schemas.microsoft.com/office/drawing/2014/main" id="{964269DC-0421-4EC4-AAFB-C96927D8CD07}"/>
               </a:ext>
             </a:extLst>
           </p:cNvPr>
@@ -1636,7 +1636,7 @@
           <p:cNvPr id="3" name="Title">
             <a:extLst xmlns:a="http://schemas.openxmlformats.org/drawingml/2006/main">
               <a:ext uri="{FF2B5EF4-FFF2-40B4-BE49-F238E27FC236}">
-                <a16:creationId xmlns:a16="http://schemas.microsoft.com/office/drawing/2014/main" id="{D75A96C1-5711-4BD4-A27F-37EECEDF2028}"/>
+                <a16:creationId xmlns:a16="http://schemas.microsoft.com/office/drawing/2014/main" id="{4D49DBA7-F506-4B28-BDE1-977180FF6D62}"/>
               </a:ext>
             </a:extLst>
           </p:cNvPr>
@@ -1865,7 +1865,7 @@
           <p:cNvPr id="2" name="Body">
             <a:extLst xmlns:a="http://schemas.openxmlformats.org/drawingml/2006/main">
               <a:ext uri="{FF2B5EF4-FFF2-40B4-BE49-F238E27FC236}">
-                <a16:creationId xmlns:a16="http://schemas.microsoft.com/office/drawing/2014/main" id="{5BCC0924-508F-48BF-892D-0FC56657A110}"/>
+                <a16:creationId xmlns:a16="http://schemas.microsoft.com/office/drawing/2014/main" id="{63F4C2A1-27AA-47E0-91FE-4661E78D0C98}"/>
               </a:ext>
             </a:extLst>
           </p:cNvPr>
@@ -2111,7 +2111,7 @@
           <p:cNvPr id="4" name="Title">
             <a:extLst xmlns:a="http://schemas.openxmlformats.org/drawingml/2006/main">
               <a:ext uri="{FF2B5EF4-FFF2-40B4-BE49-F238E27FC236}">
-                <a16:creationId xmlns:a16="http://schemas.microsoft.com/office/drawing/2014/main" id="{1C0B2DD6-CC88-4850-BD20-ED7A079499D4}"/>
+                <a16:creationId xmlns:a16="http://schemas.microsoft.com/office/drawing/2014/main" id="{901449FF-35EF-48C8-AF37-3D73B3454682}"/>
               </a:ext>
             </a:extLst>
           </p:cNvPr>
@@ -2340,7 +2340,7 @@
           <p:cNvPr id="2" name="Left column">
             <a:extLst xmlns:a="http://schemas.openxmlformats.org/drawingml/2006/main">
               <a:ext uri="{FF2B5EF4-FFF2-40B4-BE49-F238E27FC236}">
-                <a16:creationId xmlns:a16="http://schemas.microsoft.com/office/drawing/2014/main" id="{081932F9-95C6-4448-9B88-3BA4F4D7FBB7}"/>
+                <a16:creationId xmlns:a16="http://schemas.microsoft.com/office/drawing/2014/main" id="{D8C3ED16-C60C-4213-BFF2-3A19F48FD1B0}"/>
               </a:ext>
             </a:extLst>
           </p:cNvPr>
@@ -2569,7 +2569,7 @@
           <p:cNvPr id="3" name="Right column">
             <a:extLst xmlns:a="http://schemas.openxmlformats.org/drawingml/2006/main">
               <a:ext uri="{FF2B5EF4-FFF2-40B4-BE49-F238E27FC236}">
-                <a16:creationId xmlns:a16="http://schemas.microsoft.com/office/drawing/2014/main" id="{49F9977C-2E61-45B1-BF59-60DFFBD5769A}"/>
+                <a16:creationId xmlns:a16="http://schemas.microsoft.com/office/drawing/2014/main" id="{94FE70FE-3474-4B03-89C3-87B54267389A}"/>
               </a:ext>
             </a:extLst>
           </p:cNvPr>
@@ -2815,7 +2815,7 @@
           <p:cNvPr id="3" name="Title">
             <a:extLst xmlns:a="http://schemas.openxmlformats.org/drawingml/2006/main">
               <a:ext uri="{FF2B5EF4-FFF2-40B4-BE49-F238E27FC236}">
-                <a16:creationId xmlns:a16="http://schemas.microsoft.com/office/drawing/2014/main" id="{B9B8B514-4615-42C8-9E08-7EE061D457F7}"/>
+                <a16:creationId xmlns:a16="http://schemas.microsoft.com/office/drawing/2014/main" id="{E41889D2-3A36-4B70-B943-81C4D06A918E}"/>
               </a:ext>
             </a:extLst>
           </p:cNvPr>
@@ -3044,7 +3044,7 @@
           <p:cNvPr id="2" name="Left column">
             <a:extLst xmlns:a="http://schemas.openxmlformats.org/drawingml/2006/main">
               <a:ext uri="{FF2B5EF4-FFF2-40B4-BE49-F238E27FC236}">
-                <a16:creationId xmlns:a16="http://schemas.microsoft.com/office/drawing/2014/main" id="{B3CA343D-6C22-4EE0-89E8-8BD762D797A5}"/>
+                <a16:creationId xmlns:a16="http://schemas.microsoft.com/office/drawing/2014/main" id="{DA0ECF9A-BC5A-4876-B4E8-319F36777C68}"/>
               </a:ext>
             </a:extLst>
           </p:cNvPr>
@@ -3311,12 +3311,12 @@
   </p:cSld>
   <p:clrMap bg1="lt1" tx1="dk1" bg2="lt2" tx2="dk2" accent1="accent1" accent2="accent2" accent3="accent3" accent4="accent4" accent5="accent5" accent6="accent6" hlink="hlink" folHlink="folHlink"/>
   <p:sldLayoutIdLst>
-    <p:sldLayoutId xmlns:r="http://schemas.openxmlformats.org/officeDocument/2006/relationships" id="2147483649" r:id="Ra753778886614c56"/>
-    <p:sldLayoutId xmlns:r="http://schemas.openxmlformats.org/officeDocument/2006/relationships" id="2147483650" r:id="R15e4aa419e3646fc"/>
-    <p:sldLayoutId xmlns:r="http://schemas.openxmlformats.org/officeDocument/2006/relationships" id="2147483651" r:id="R38ba5dcde86340fe"/>
-    <p:sldLayoutId xmlns:r="http://schemas.openxmlformats.org/officeDocument/2006/relationships" id="2147483652" r:id="Rd82c59db516a4d02"/>
-    <p:sldLayoutId xmlns:r="http://schemas.openxmlformats.org/officeDocument/2006/relationships" id="2147483653" r:id="Rffb08e1ff2ca4712"/>
-    <p:sldLayoutId xmlns:r="http://schemas.openxmlformats.org/officeDocument/2006/relationships" id="2147483654" r:id="R4509b27861234361"/>
+    <p:sldLayoutId xmlns:r="http://schemas.openxmlformats.org/officeDocument/2006/relationships" id="2147483649" r:id="Rf2204d7cfcd34067"/>
+    <p:sldLayoutId xmlns:r="http://schemas.openxmlformats.org/officeDocument/2006/relationships" id="2147483650" r:id="R55d05873156c4a72"/>
+    <p:sldLayoutId xmlns:r="http://schemas.openxmlformats.org/officeDocument/2006/relationships" id="2147483651" r:id="Rcf2843dbbbc24790"/>
+    <p:sldLayoutId xmlns:r="http://schemas.openxmlformats.org/officeDocument/2006/relationships" id="2147483652" r:id="R7365c1f1a4b2439d"/>
+    <p:sldLayoutId xmlns:r="http://schemas.openxmlformats.org/officeDocument/2006/relationships" id="2147483653" r:id="Re6b4d027909b487a"/>
+    <p:sldLayoutId xmlns:r="http://schemas.openxmlformats.org/officeDocument/2006/relationships" id="2147483654" r:id="R15958563ccb74756"/>
   </p:sldLayoutIdLst>
   <p:txStyles>
     <p:titleStyle>
@@ -3867,7 +3867,7 @@
           <p:cNvPr id="5" name="">
             <a:extLst xmlns:a="http://schemas.openxmlformats.org/drawingml/2006/main">
               <a:ext uri="{FF2B5EF4-FFF2-40B4-BE49-F238E27FC236}">
-                <a16:creationId xmlns:a16="http://schemas.microsoft.com/office/drawing/2014/main" id="{372962E8-C039-405F-9E79-BBCB5DC77F8C}"/>
+                <a16:creationId xmlns:a16="http://schemas.microsoft.com/office/drawing/2014/main" id="{58348E89-F086-4F8B-B854-34367C9C2DA1}"/>
               </a:ext>
             </a:extLst>
           </p:cNvPr>
@@ -4023,7 +4023,7 @@
           <p:cNvPr id="2" name="">
             <a:extLst xmlns:a="http://schemas.openxmlformats.org/drawingml/2006/main">
               <a:ext uri="{FF2B5EF4-FFF2-40B4-BE49-F238E27FC236}">
-                <a16:creationId xmlns:a16="http://schemas.microsoft.com/office/drawing/2014/main" id="{1A75FFAA-BB6E-4714-8E97-76C6965D4916}"/>
+                <a16:creationId xmlns:a16="http://schemas.microsoft.com/office/drawing/2014/main" id="{A8B6EE4E-4FB3-4C08-9984-6F4F41756475}"/>
               </a:ext>
             </a:extLst>
           </p:cNvPr>
@@ -4202,7 +4202,7 @@
           <p:cNvPr id="3" name="">
             <a:extLst xmlns:a="http://schemas.openxmlformats.org/drawingml/2006/main">
               <a:ext uri="{FF2B5EF4-FFF2-40B4-BE49-F238E27FC236}">
-                <a16:creationId xmlns:a16="http://schemas.microsoft.com/office/drawing/2014/main" id="{7347933B-D384-43B1-99AC-44485332A0E8}"/>
+                <a16:creationId xmlns:a16="http://schemas.microsoft.com/office/drawing/2014/main" id="{8E148F0E-98AF-4705-BDF3-25D337E64982}"/>
               </a:ext>
             </a:extLst>
           </p:cNvPr>
@@ -4358,7 +4358,7 @@
           <p:cNvPr id="4" name="">
             <a:extLst xmlns:a="http://schemas.openxmlformats.org/drawingml/2006/main">
               <a:ext uri="{FF2B5EF4-FFF2-40B4-BE49-F238E27FC236}">
-                <a16:creationId xmlns:a16="http://schemas.microsoft.com/office/drawing/2014/main" id="{833E736B-735C-49BB-B02A-1DF4A1238D13}"/>
+                <a16:creationId xmlns:a16="http://schemas.microsoft.com/office/drawing/2014/main" id="{641ADAF5-ACD8-4BC4-ACAA-C0FBC832358D}"/>
               </a:ext>
             </a:extLst>
           </p:cNvPr>
@@ -4368,7 +4368,7 @@
           <p:nvPr/>
         </p:nvPicPr>
         <p:blipFill>
-          <a:blip xmlns:r="http://schemas.openxmlformats.org/officeDocument/2006/relationships" xmlns:a="http://schemas.openxmlformats.org/drawingml/2006/main" r:embed="R11915d189c3f4592"/>
+          <a:blip xmlns:r="http://schemas.openxmlformats.org/officeDocument/2006/relationships" xmlns:a="http://schemas.openxmlformats.org/drawingml/2006/main" r:embed="R258d368157e54da3"/>
           <a:stretch xmlns:a="http://schemas.openxmlformats.org/drawingml/2006/main"/>
         </p:blipFill>
         <p:spPr>
@@ -4384,7 +4384,7 @@
     </p:spTree>
     <p:extLst>
       <p:ext uri="{BB962C8B-B14F-4D97-AF65-F5344CB8AC3E}">
-        <p14:creationId xmlns:p14="http://schemas.microsoft.com/office/powerpoint/2010/main" val="99742265"/>
+        <p14:creationId xmlns:p14="http://schemas.microsoft.com/office/powerpoint/2010/main" val="554674172"/>
       </p:ext>
     </p:extLst>
   </p:cSld>
@@ -4415,7 +4415,7 @@
           <p:cNvPr id="5" name="">
             <a:extLst xmlns:a="http://schemas.openxmlformats.org/drawingml/2006/main">
               <a:ext uri="{FF2B5EF4-FFF2-40B4-BE49-F238E27FC236}">
-                <a16:creationId xmlns:a16="http://schemas.microsoft.com/office/drawing/2014/main" id="{5EE0F31F-D23C-4219-94E4-C0DAD2DB6C65}"/>
+                <a16:creationId xmlns:a16="http://schemas.microsoft.com/office/drawing/2014/main" id="{06C83BA7-1622-4695-A0F2-1D249B0FED61}"/>
               </a:ext>
             </a:extLst>
           </p:cNvPr>
@@ -4571,7 +4571,7 @@
           <p:cNvPr id="2" name="">
             <a:extLst xmlns:a="http://schemas.openxmlformats.org/drawingml/2006/main">
               <a:ext uri="{FF2B5EF4-FFF2-40B4-BE49-F238E27FC236}">
-                <a16:creationId xmlns:a16="http://schemas.microsoft.com/office/drawing/2014/main" id="{1441D0C2-D838-4B94-A819-A9AEC9630CD9}"/>
+                <a16:creationId xmlns:a16="http://schemas.microsoft.com/office/drawing/2014/main" id="{DEADBB6F-DDC3-459C-9FAF-032746A48702}"/>
               </a:ext>
             </a:extLst>
           </p:cNvPr>
@@ -4727,7 +4727,7 @@
           <p:cNvPr id="3" name="">
             <a:extLst xmlns:a="http://schemas.openxmlformats.org/drawingml/2006/main">
               <a:ext uri="{FF2B5EF4-FFF2-40B4-BE49-F238E27FC236}">
-                <a16:creationId xmlns:a16="http://schemas.microsoft.com/office/drawing/2014/main" id="{D9EBBA4B-3828-4221-806D-BBF71B935C38}"/>
+                <a16:creationId xmlns:a16="http://schemas.microsoft.com/office/drawing/2014/main" id="{7533AE28-F4F0-4AA3-A473-E8CA5C913F2A}"/>
               </a:ext>
             </a:extLst>
           </p:cNvPr>
@@ -4883,7 +4883,7 @@
           <p:cNvPr id="4" name="">
             <a:extLst xmlns:a="http://schemas.openxmlformats.org/drawingml/2006/main">
               <a:ext uri="{FF2B5EF4-FFF2-40B4-BE49-F238E27FC236}">
-                <a16:creationId xmlns:a16="http://schemas.microsoft.com/office/drawing/2014/main" id="{D2DB65A0-EF63-4D1C-A2D9-B4FC5C960031}"/>
+                <a16:creationId xmlns:a16="http://schemas.microsoft.com/office/drawing/2014/main" id="{1F9F4491-62A0-444B-BCDE-D5285D832DDF}"/>
               </a:ext>
             </a:extLst>
           </p:cNvPr>
@@ -5037,7 +5037,7 @@
     </p:spTree>
     <p:extLst>
       <p:ext uri="{BB962C8B-B14F-4D97-AF65-F5344CB8AC3E}">
-        <p14:creationId xmlns:p14="http://schemas.microsoft.com/office/powerpoint/2010/main" val="155187898"/>
+        <p14:creationId xmlns:p14="http://schemas.microsoft.com/office/powerpoint/2010/main" val="1787290737"/>
       </p:ext>
     </p:extLst>
   </p:cSld>
@@ -5068,7 +5068,7 @@
           <p:cNvPr id="5" name="">
             <a:extLst xmlns:a="http://schemas.openxmlformats.org/drawingml/2006/main">
               <a:ext uri="{FF2B5EF4-FFF2-40B4-BE49-F238E27FC236}">
-                <a16:creationId xmlns:a16="http://schemas.microsoft.com/office/drawing/2014/main" id="{7F841051-EF8D-450A-BBB8-9E86F5BD62E0}"/>
+                <a16:creationId xmlns:a16="http://schemas.microsoft.com/office/drawing/2014/main" id="{A0905AF7-7BF3-4334-BE3C-3F98717C4DF3}"/>
               </a:ext>
             </a:extLst>
           </p:cNvPr>
@@ -5224,7 +5224,7 @@
           <p:cNvPr id="2" name="">
             <a:extLst xmlns:a="http://schemas.openxmlformats.org/drawingml/2006/main">
               <a:ext uri="{FF2B5EF4-FFF2-40B4-BE49-F238E27FC236}">
-                <a16:creationId xmlns:a16="http://schemas.microsoft.com/office/drawing/2014/main" id="{0D2FE094-D5BC-4A58-A5BB-5493D967EA52}"/>
+                <a16:creationId xmlns:a16="http://schemas.microsoft.com/office/drawing/2014/main" id="{FCA7EC96-122A-42B4-958A-4676151A2503}"/>
               </a:ext>
             </a:extLst>
           </p:cNvPr>
@@ -5380,7 +5380,7 @@
           <p:cNvPr id="3" name="">
             <a:extLst xmlns:a="http://schemas.openxmlformats.org/drawingml/2006/main">
               <a:ext uri="{FF2B5EF4-FFF2-40B4-BE49-F238E27FC236}">
-                <a16:creationId xmlns:a16="http://schemas.microsoft.com/office/drawing/2014/main" id="{6FFD9359-50A6-458A-8DAB-0349B25458FB}"/>
+                <a16:creationId xmlns:a16="http://schemas.microsoft.com/office/drawing/2014/main" id="{A1717A28-2ABD-49B3-B707-01416E5911A7}"/>
               </a:ext>
             </a:extLst>
           </p:cNvPr>
@@ -5536,7 +5536,7 @@
           <p:cNvPr id="4" name="">
             <a:extLst xmlns:a="http://schemas.openxmlformats.org/drawingml/2006/main">
               <a:ext uri="{FF2B5EF4-FFF2-40B4-BE49-F238E27FC236}">
-                <a16:creationId xmlns:a16="http://schemas.microsoft.com/office/drawing/2014/main" id="{94E1DB70-D99E-41B4-80A0-1B361795C060}"/>
+                <a16:creationId xmlns:a16="http://schemas.microsoft.com/office/drawing/2014/main" id="{F049BAC3-B0CB-4D4B-8766-C6EEB408E968}"/>
               </a:ext>
             </a:extLst>
           </p:cNvPr>
@@ -5690,7 +5690,7 @@
     </p:spTree>
     <p:extLst>
       <p:ext uri="{BB962C8B-B14F-4D97-AF65-F5344CB8AC3E}">
-        <p14:creationId xmlns:p14="http://schemas.microsoft.com/office/powerpoint/2010/main" val="777253700"/>
+        <p14:creationId xmlns:p14="http://schemas.microsoft.com/office/powerpoint/2010/main" val="1299662861"/>
       </p:ext>
     </p:extLst>
   </p:cSld>
@@ -5721,7 +5721,7 @@
           <p:cNvPr id="5" name="">
             <a:extLst xmlns:a="http://schemas.openxmlformats.org/drawingml/2006/main">
               <a:ext uri="{FF2B5EF4-FFF2-40B4-BE49-F238E27FC236}">
-                <a16:creationId xmlns:a16="http://schemas.microsoft.com/office/drawing/2014/main" id="{311729C2-2168-419A-A51F-3D3F1D118D6F}"/>
+                <a16:creationId xmlns:a16="http://schemas.microsoft.com/office/drawing/2014/main" id="{2AD5170F-894F-46F2-AE07-BFF81BDE7BEA}"/>
               </a:ext>
             </a:extLst>
           </p:cNvPr>
@@ -5877,7 +5877,7 @@
           <p:cNvPr id="2" name="">
             <a:extLst xmlns:a="http://schemas.openxmlformats.org/drawingml/2006/main">
               <a:ext uri="{FF2B5EF4-FFF2-40B4-BE49-F238E27FC236}">
-                <a16:creationId xmlns:a16="http://schemas.microsoft.com/office/drawing/2014/main" id="{C1AEBEB0-8532-4E1B-8FB7-08280200E339}"/>
+                <a16:creationId xmlns:a16="http://schemas.microsoft.com/office/drawing/2014/main" id="{56AA03F3-2F09-4436-A818-F8024FDA90E3}"/>
               </a:ext>
             </a:extLst>
           </p:cNvPr>
@@ -6033,7 +6033,7 @@
           <p:cNvPr id="3" name="">
             <a:extLst xmlns:a="http://schemas.openxmlformats.org/drawingml/2006/main">
               <a:ext uri="{FF2B5EF4-FFF2-40B4-BE49-F238E27FC236}">
-                <a16:creationId xmlns:a16="http://schemas.microsoft.com/office/drawing/2014/main" id="{5D2008D2-FCC8-461D-97A5-A7DD0DF6E6DD}"/>
+                <a16:creationId xmlns:a16="http://schemas.microsoft.com/office/drawing/2014/main" id="{15ED19F2-3357-4A3D-93F8-FEBE1F20C305}"/>
               </a:ext>
             </a:extLst>
           </p:cNvPr>
@@ -6189,7 +6189,7 @@
           <p:cNvPr id="4" name="">
             <a:extLst xmlns:a="http://schemas.openxmlformats.org/drawingml/2006/main">
               <a:ext uri="{FF2B5EF4-FFF2-40B4-BE49-F238E27FC236}">
-                <a16:creationId xmlns:a16="http://schemas.microsoft.com/office/drawing/2014/main" id="{EC4B9F0F-7254-48DF-B24A-4A0C9CE49663}"/>
+                <a16:creationId xmlns:a16="http://schemas.microsoft.com/office/drawing/2014/main" id="{611FEE47-245F-45B7-BBC6-021DFC5DE165}"/>
               </a:ext>
             </a:extLst>
           </p:cNvPr>
@@ -6343,7 +6343,7 @@
     </p:spTree>
     <p:extLst>
       <p:ext uri="{BB962C8B-B14F-4D97-AF65-F5344CB8AC3E}">
-        <p14:creationId xmlns:p14="http://schemas.microsoft.com/office/powerpoint/2010/main" val="1115893963"/>
+        <p14:creationId xmlns:p14="http://schemas.microsoft.com/office/powerpoint/2010/main" val="1599310064"/>
       </p:ext>
     </p:extLst>
   </p:cSld>
@@ -6374,7 +6374,7 @@
           <p:cNvPr id="5" name="">
             <a:extLst xmlns:a="http://schemas.openxmlformats.org/drawingml/2006/main">
               <a:ext uri="{FF2B5EF4-FFF2-40B4-BE49-F238E27FC236}">
-                <a16:creationId xmlns:a16="http://schemas.microsoft.com/office/drawing/2014/main" id="{FDCB7372-6FC0-44E3-94A2-50B682A5EEAB}"/>
+                <a16:creationId xmlns:a16="http://schemas.microsoft.com/office/drawing/2014/main" id="{085A61B9-D7C5-444F-B969-3D1F05991FF4}"/>
               </a:ext>
             </a:extLst>
           </p:cNvPr>
@@ -6530,7 +6530,7 @@
           <p:cNvPr id="2" name="">
             <a:extLst xmlns:a="http://schemas.openxmlformats.org/drawingml/2006/main">
               <a:ext uri="{FF2B5EF4-FFF2-40B4-BE49-F238E27FC236}">
-                <a16:creationId xmlns:a16="http://schemas.microsoft.com/office/drawing/2014/main" id="{090823FA-744E-43FE-8D56-FFDCA14DFA37}"/>
+                <a16:creationId xmlns:a16="http://schemas.microsoft.com/office/drawing/2014/main" id="{506787AD-4603-4D2E-9D83-15CA03A8457D}"/>
               </a:ext>
             </a:extLst>
           </p:cNvPr>
@@ -6686,7 +6686,7 @@
           <p:cNvPr id="3" name="">
             <a:extLst xmlns:a="http://schemas.openxmlformats.org/drawingml/2006/main">
               <a:ext uri="{FF2B5EF4-FFF2-40B4-BE49-F238E27FC236}">
-                <a16:creationId xmlns:a16="http://schemas.microsoft.com/office/drawing/2014/main" id="{0503F963-5847-4FE0-8344-1B592DBAE190}"/>
+                <a16:creationId xmlns:a16="http://schemas.microsoft.com/office/drawing/2014/main" id="{051B159E-771D-4EBE-A267-7AE4ADC63937}"/>
               </a:ext>
             </a:extLst>
           </p:cNvPr>
@@ -6842,7 +6842,7 @@
           <p:cNvPr id="4" name="">
             <a:extLst xmlns:a="http://schemas.openxmlformats.org/drawingml/2006/main">
               <a:ext uri="{FF2B5EF4-FFF2-40B4-BE49-F238E27FC236}">
-                <a16:creationId xmlns:a16="http://schemas.microsoft.com/office/drawing/2014/main" id="{FF31629F-A6A4-4D97-BB42-C9C7DD803B6B}"/>
+                <a16:creationId xmlns:a16="http://schemas.microsoft.com/office/drawing/2014/main" id="{C477118D-028E-43A7-9FDF-8D0D60FC9616}"/>
               </a:ext>
             </a:extLst>
           </p:cNvPr>
@@ -6996,7 +6996,7 @@
     </p:spTree>
     <p:extLst>
       <p:ext uri="{BB962C8B-B14F-4D97-AF65-F5344CB8AC3E}">
-        <p14:creationId xmlns:p14="http://schemas.microsoft.com/office/powerpoint/2010/main" val="1234409801"/>
+        <p14:creationId xmlns:p14="http://schemas.microsoft.com/office/powerpoint/2010/main" val="1556078492"/>
       </p:ext>
     </p:extLst>
   </p:cSld>
@@ -7027,7 +7027,7 @@
           <p:cNvPr id="5" name="">
             <a:extLst xmlns:a="http://schemas.openxmlformats.org/drawingml/2006/main">
               <a:ext uri="{FF2B5EF4-FFF2-40B4-BE49-F238E27FC236}">
-                <a16:creationId xmlns:a16="http://schemas.microsoft.com/office/drawing/2014/main" id="{C1CFF9B9-899C-4ADA-8002-86070AC65961}"/>
+                <a16:creationId xmlns:a16="http://schemas.microsoft.com/office/drawing/2014/main" id="{A6382D1A-9900-4497-B809-6D9F7240845F}"/>
               </a:ext>
             </a:extLst>
           </p:cNvPr>
@@ -7183,7 +7183,7 @@
           <p:cNvPr id="2" name="">
             <a:extLst xmlns:a="http://schemas.openxmlformats.org/drawingml/2006/main">
               <a:ext uri="{FF2B5EF4-FFF2-40B4-BE49-F238E27FC236}">
-                <a16:creationId xmlns:a16="http://schemas.microsoft.com/office/drawing/2014/main" id="{CE391010-0476-4C6C-9C43-A653BA700F3D}"/>
+                <a16:creationId xmlns:a16="http://schemas.microsoft.com/office/drawing/2014/main" id="{BAB0D562-B27C-4EFC-94DF-BEEDE5BF7C06}"/>
               </a:ext>
             </a:extLst>
           </p:cNvPr>
@@ -7339,7 +7339,7 @@
           <p:cNvPr id="3" name="">
             <a:extLst xmlns:a="http://schemas.openxmlformats.org/drawingml/2006/main">
               <a:ext uri="{FF2B5EF4-FFF2-40B4-BE49-F238E27FC236}">
-                <a16:creationId xmlns:a16="http://schemas.microsoft.com/office/drawing/2014/main" id="{FA1FD217-4B59-4F8D-B3AD-12D380A78457}"/>
+                <a16:creationId xmlns:a16="http://schemas.microsoft.com/office/drawing/2014/main" id="{AB643399-0E71-440D-9341-79AD5242B318}"/>
               </a:ext>
             </a:extLst>
           </p:cNvPr>
@@ -7485,7 +7485,7 @@
                 <a:ea typeface="Arial"/>
                 <a:cs typeface="Arial"/>
               </a:rPr>
-              <a:t>Four circuits compile with full proving assets. Twenty-two local tests cover behavior and attacks.</a:t>
+              <a:t>Four circuits compile with full proving assets. All 28 tests and the GitHub build checks pass.</a:t>
             </a:r>
           </a:p>
         </p:txBody>
@@ -7495,7 +7495,7 @@
           <p:cNvPr id="4" name="">
             <a:extLst xmlns:a="http://schemas.openxmlformats.org/drawingml/2006/main">
               <a:ext uri="{FF2B5EF4-FFF2-40B4-BE49-F238E27FC236}">
-                <a16:creationId xmlns:a16="http://schemas.microsoft.com/office/drawing/2014/main" id="{BB9E13CD-2D9D-4638-ABC3-02098E7D940D}"/>
+                <a16:creationId xmlns:a16="http://schemas.microsoft.com/office/drawing/2014/main" id="{935B68CA-9527-4E46-A06F-CC3E547EC13A}"/>
               </a:ext>
             </a:extLst>
           </p:cNvPr>
@@ -7641,7 +7641,7 @@
                 <a:ea typeface="Arial"/>
                 <a:cs typeface="Arial"/>
               </a:rPr>
-              <a:t>The browser separates propose, approve, deposit and execute. Live deployment evidence is tracked separately.</a:t>
+              <a:t>Local network: two approvals and a payout confirmed. 100,000 base units paid; 900,000 retained.</a:t>
             </a:r>
           </a:p>
         </p:txBody>
@@ -7649,7 +7649,7 @@
     </p:spTree>
     <p:extLst>
       <p:ext uri="{BB962C8B-B14F-4D97-AF65-F5344CB8AC3E}">
-        <p14:creationId xmlns:p14="http://schemas.microsoft.com/office/powerpoint/2010/main" val="1708761052"/>
+        <p14:creationId xmlns:p14="http://schemas.microsoft.com/office/powerpoint/2010/main" val="318541601"/>
       </p:ext>
     </p:extLst>
   </p:cSld>
@@ -7680,7 +7680,7 @@
           <p:cNvPr id="5" name="">
             <a:extLst xmlns:a="http://schemas.openxmlformats.org/drawingml/2006/main">
               <a:ext uri="{FF2B5EF4-FFF2-40B4-BE49-F238E27FC236}">
-                <a16:creationId xmlns:a16="http://schemas.microsoft.com/office/drawing/2014/main" id="{611ECF87-D70E-45EC-B440-1FA836A73653}"/>
+                <a16:creationId xmlns:a16="http://schemas.microsoft.com/office/drawing/2014/main" id="{0E24360E-4B03-452E-91FF-794A8F376927}"/>
               </a:ext>
             </a:extLst>
           </p:cNvPr>
@@ -7836,7 +7836,7 @@
           <p:cNvPr id="2" name="">
             <a:extLst xmlns:a="http://schemas.openxmlformats.org/drawingml/2006/main">
               <a:ext uri="{FF2B5EF4-FFF2-40B4-BE49-F238E27FC236}">
-                <a16:creationId xmlns:a16="http://schemas.microsoft.com/office/drawing/2014/main" id="{02A2A38A-BC2F-4247-B526-33DF620BC49C}"/>
+                <a16:creationId xmlns:a16="http://schemas.microsoft.com/office/drawing/2014/main" id="{E8972D3D-90D2-4935-996E-76591D8B0EF0}"/>
               </a:ext>
             </a:extLst>
           </p:cNvPr>
@@ -7992,7 +7992,7 @@
           <p:cNvPr id="3" name="">
             <a:extLst xmlns:a="http://schemas.openxmlformats.org/drawingml/2006/main">
               <a:ext uri="{FF2B5EF4-FFF2-40B4-BE49-F238E27FC236}">
-                <a16:creationId xmlns:a16="http://schemas.microsoft.com/office/drawing/2014/main" id="{D75856E7-B2CB-4185-9154-677A9433EBB3}"/>
+                <a16:creationId xmlns:a16="http://schemas.microsoft.com/office/drawing/2014/main" id="{F6527364-DCE5-4AAE-8964-B97013487BA4}"/>
               </a:ext>
             </a:extLst>
           </p:cNvPr>
@@ -8148,7 +8148,7 @@
           <p:cNvPr id="4" name="">
             <a:extLst xmlns:a="http://schemas.openxmlformats.org/drawingml/2006/main">
               <a:ext uri="{FF2B5EF4-FFF2-40B4-BE49-F238E27FC236}">
-                <a16:creationId xmlns:a16="http://schemas.microsoft.com/office/drawing/2014/main" id="{B8A47ED0-EB02-4E87-AF34-EF3BB80D6F66}"/>
+                <a16:creationId xmlns:a16="http://schemas.microsoft.com/office/drawing/2014/main" id="{3AC4D319-E85C-4CDD-B22D-5580DD70BBA4}"/>
               </a:ext>
             </a:extLst>
           </p:cNvPr>
@@ -8302,7 +8302,7 @@
     </p:spTree>
     <p:extLst>
       <p:ext uri="{BB962C8B-B14F-4D97-AF65-F5344CB8AC3E}">
-        <p14:creationId xmlns:p14="http://schemas.microsoft.com/office/powerpoint/2010/main" val="1415010031"/>
+        <p14:creationId xmlns:p14="http://schemas.microsoft.com/office/powerpoint/2010/main" val="1454591793"/>
       </p:ext>
     </p:extLst>
   </p:cSld>

</xml_diff>